<commit_message>
Add Motz Loan Prediction project
</commit_message>
<xml_diff>
--- a/presentation/DIAL3110_Loan_Prediction_Slides.pptx
+++ b/presentation/DIAL3110_Loan_Prediction_Slides.pptx
@@ -3298,6 +3298,53 @@
                         <a:rPr sz="1300">
                           <a:latin typeface="Arial Narrow"/>
                         </a:rPr>
+                        <a:t>Support Vector Machine</a:t>
+                      </a:r>
+                    </a:p>
+                  </a:txBody>
+                  <a:tcPr/>
+                </a:tc>
+                <a:tc>
+                  <a:txBody>
+                    <a:bodyPr/>
+                    <a:lstStyle/>
+                    <a:p>
+                      <a:r>
+                        <a:rPr sz="1300">
+                          <a:latin typeface="Arial Narrow"/>
+                        </a:rPr>
+                        <a:t>0.792</a:t>
+                      </a:r>
+                    </a:p>
+                  </a:txBody>
+                  <a:tcPr/>
+                </a:tc>
+                <a:tc>
+                  <a:txBody>
+                    <a:bodyPr/>
+                    <a:lstStyle/>
+                    <a:p>
+                      <a:r>
+                        <a:rPr sz="1300">
+                          <a:latin typeface="Arial Narrow"/>
+                        </a:rPr>
+                        <a:t>0.764</a:t>
+                      </a:r>
+                    </a:p>
+                  </a:txBody>
+                  <a:tcPr/>
+                </a:tc>
+              </a:tr>
+              <a:tr h="411480">
+                <a:tc>
+                  <a:txBody>
+                    <a:bodyPr/>
+                    <a:lstStyle/>
+                    <a:p>
+                      <a:r>
+                        <a:rPr sz="1300">
+                          <a:latin typeface="Arial Narrow"/>
+                        </a:rPr>
                         <a:t>Soft Voting Ensemble</a:t>
                       </a:r>
                     </a:p>
@@ -3313,7 +3360,7 @@
                         <a:rPr sz="1300">
                           <a:latin typeface="Arial Narrow"/>
                         </a:rPr>
-                        <a:t>0.845</a:t>
+                        <a:t>0.790</a:t>
                       </a:r>
                     </a:p>
                   </a:txBody>
@@ -3328,7 +3375,54 @@
                         <a:rPr sz="1300">
                           <a:latin typeface="Arial Narrow"/>
                         </a:rPr>
-                        <a:t>0.697</a:t>
+                        <a:t>0.774</a:t>
+                      </a:r>
+                    </a:p>
+                  </a:txBody>
+                  <a:tcPr/>
+                </a:tc>
+              </a:tr>
+              <a:tr h="411480">
+                <a:tc>
+                  <a:txBody>
+                    <a:bodyPr/>
+                    <a:lstStyle/>
+                    <a:p>
+                      <a:r>
+                        <a:rPr sz="1300">
+                          <a:latin typeface="Arial Narrow"/>
+                        </a:rPr>
+                        <a:t>Logistic Regression</a:t>
+                      </a:r>
+                    </a:p>
+                  </a:txBody>
+                  <a:tcPr/>
+                </a:tc>
+                <a:tc>
+                  <a:txBody>
+                    <a:bodyPr/>
+                    <a:lstStyle/>
+                    <a:p>
+                      <a:r>
+                        <a:rPr sz="1300">
+                          <a:latin typeface="Arial Narrow"/>
+                        </a:rPr>
+                        <a:t>0.790</a:t>
+                      </a:r>
+                    </a:p>
+                  </a:txBody>
+                  <a:tcPr/>
+                </a:tc>
+                <a:tc>
+                  <a:txBody>
+                    <a:bodyPr/>
+                    <a:lstStyle/>
+                    <a:p>
+                      <a:r>
+                        <a:rPr sz="1300">
+                          <a:latin typeface="Arial Narrow"/>
+                        </a:rPr>
+                        <a:t>0.727</a:t>
                       </a:r>
                     </a:p>
                   </a:txBody>
@@ -3360,7 +3454,7 @@
                         <a:rPr sz="1300">
                           <a:latin typeface="Arial Narrow"/>
                         </a:rPr>
-                        <a:t>0.844</a:t>
+                        <a:t>0.786</a:t>
                       </a:r>
                     </a:p>
                   </a:txBody>
@@ -3375,7 +3469,7 @@
                         <a:rPr sz="1300">
                           <a:latin typeface="Arial Narrow"/>
                         </a:rPr>
-                        <a:t>0.741</a:t>
+                        <a:t>0.776</a:t>
                       </a:r>
                     </a:p>
                   </a:txBody>
@@ -3392,7 +3486,7 @@
                         <a:rPr sz="1300">
                           <a:latin typeface="Arial Narrow"/>
                         </a:rPr>
-                        <a:t>Logistic Regression</a:t>
+                        <a:t>Random Forest</a:t>
                       </a:r>
                     </a:p>
                   </a:txBody>
@@ -3407,7 +3501,7 @@
                         <a:rPr sz="1300">
                           <a:latin typeface="Arial Narrow"/>
                         </a:rPr>
-                        <a:t>0.844</a:t>
+                        <a:t>0.782</a:t>
                       </a:r>
                     </a:p>
                   </a:txBody>
@@ -3422,7 +3516,7 @@
                         <a:rPr sz="1300">
                           <a:latin typeface="Arial Narrow"/>
                         </a:rPr>
-                        <a:t>0.733</a:t>
+                        <a:t>0.781</a:t>
                       </a:r>
                     </a:p>
                   </a:txBody>
@@ -3439,7 +3533,7 @@
                         <a:rPr sz="1300">
                           <a:latin typeface="Arial Narrow"/>
                         </a:rPr>
-                        <a:t>Support Vector Machine</a:t>
+                        <a:t>K-Nearest Neighbours</a:t>
                       </a:r>
                     </a:p>
                   </a:txBody>
@@ -3454,7 +3548,7 @@
                         <a:rPr sz="1300">
                           <a:latin typeface="Arial Narrow"/>
                         </a:rPr>
-                        <a:t>0.844</a:t>
+                        <a:t>0.770</a:t>
                       </a:r>
                     </a:p>
                   </a:txBody>
@@ -3469,7 +3563,54 @@
                         <a:rPr sz="1300">
                           <a:latin typeface="Arial Narrow"/>
                         </a:rPr>
-                        <a:t>0.707</a:t>
+                        <a:t>0.728</a:t>
+                      </a:r>
+                    </a:p>
+                  </a:txBody>
+                  <a:tcPr/>
+                </a:tc>
+              </a:tr>
+              <a:tr h="411480">
+                <a:tc>
+                  <a:txBody>
+                    <a:bodyPr/>
+                    <a:lstStyle/>
+                    <a:p>
+                      <a:r>
+                        <a:rPr sz="1300">
+                          <a:latin typeface="Arial Narrow"/>
+                        </a:rPr>
+                        <a:t>Gradient Boosting</a:t>
+                      </a:r>
+                    </a:p>
+                  </a:txBody>
+                  <a:tcPr/>
+                </a:tc>
+                <a:tc>
+                  <a:txBody>
+                    <a:bodyPr/>
+                    <a:lstStyle/>
+                    <a:p>
+                      <a:r>
+                        <a:rPr sz="1300">
+                          <a:latin typeface="Arial Narrow"/>
+                        </a:rPr>
+                        <a:t>0.770</a:t>
+                      </a:r>
+                    </a:p>
+                  </a:txBody>
+                  <a:tcPr/>
+                </a:tc>
+                <a:tc>
+                  <a:txBody>
+                    <a:bodyPr/>
+                    <a:lstStyle/>
+                    <a:p>
+                      <a:r>
+                        <a:rPr sz="1300">
+                          <a:latin typeface="Arial Narrow"/>
+                        </a:rPr>
+                        <a:t>0.734</a:t>
                       </a:r>
                     </a:p>
                   </a:txBody>
@@ -3501,7 +3642,7 @@
                         <a:rPr sz="1300">
                           <a:latin typeface="Arial Narrow"/>
                         </a:rPr>
-                        <a:t>0.833</a:t>
+                        <a:t>0.770</a:t>
                       </a:r>
                     </a:p>
                   </a:txBody>
@@ -3516,148 +3657,7 @@
                         <a:rPr sz="1300">
                           <a:latin typeface="Arial Narrow"/>
                         </a:rPr>
-                        <a:t>0.741</a:t>
-                      </a:r>
-                    </a:p>
-                  </a:txBody>
-                  <a:tcPr/>
-                </a:tc>
-              </a:tr>
-              <a:tr h="411480">
-                <a:tc>
-                  <a:txBody>
-                    <a:bodyPr/>
-                    <a:lstStyle/>
-                    <a:p>
-                      <a:r>
-                        <a:rPr sz="1300">
-                          <a:latin typeface="Arial Narrow"/>
-                        </a:rPr>
-                        <a:t>Gradient Boosting</a:t>
-                      </a:r>
-                    </a:p>
-                  </a:txBody>
-                  <a:tcPr/>
-                </a:tc>
-                <a:tc>
-                  <a:txBody>
-                    <a:bodyPr/>
-                    <a:lstStyle/>
-                    <a:p>
-                      <a:r>
-                        <a:rPr sz="1300">
-                          <a:latin typeface="Arial Narrow"/>
-                        </a:rPr>
-                        <a:t>0.833</a:t>
-                      </a:r>
-                    </a:p>
-                  </a:txBody>
-                  <a:tcPr/>
-                </a:tc>
-                <a:tc>
-                  <a:txBody>
-                    <a:bodyPr/>
-                    <a:lstStyle/>
-                    <a:p>
-                      <a:r>
-                        <a:rPr sz="1300">
-                          <a:latin typeface="Arial Narrow"/>
-                        </a:rPr>
-                        <a:t>0.685</a:t>
-                      </a:r>
-                    </a:p>
-                  </a:txBody>
-                  <a:tcPr/>
-                </a:tc>
-              </a:tr>
-              <a:tr h="411480">
-                <a:tc>
-                  <a:txBody>
-                    <a:bodyPr/>
-                    <a:lstStyle/>
-                    <a:p>
-                      <a:r>
-                        <a:rPr sz="1300">
-                          <a:latin typeface="Arial Narrow"/>
-                        </a:rPr>
-                        <a:t>Random Forest</a:t>
-                      </a:r>
-                    </a:p>
-                  </a:txBody>
-                  <a:tcPr/>
-                </a:tc>
-                <a:tc>
-                  <a:txBody>
-                    <a:bodyPr/>
-                    <a:lstStyle/>
-                    <a:p>
-                      <a:r>
-                        <a:rPr sz="1300">
-                          <a:latin typeface="Arial Narrow"/>
-                        </a:rPr>
-                        <a:t>0.833</a:t>
-                      </a:r>
-                    </a:p>
-                  </a:txBody>
-                  <a:tcPr/>
-                </a:tc>
-                <a:tc>
-                  <a:txBody>
-                    <a:bodyPr/>
-                    <a:lstStyle/>
-                    <a:p>
-                      <a:r>
-                        <a:rPr sz="1300">
-                          <a:latin typeface="Arial Narrow"/>
-                        </a:rPr>
-                        <a:t>0.683</a:t>
-                      </a:r>
-                    </a:p>
-                  </a:txBody>
-                  <a:tcPr/>
-                </a:tc>
-              </a:tr>
-              <a:tr h="411480">
-                <a:tc>
-                  <a:txBody>
-                    <a:bodyPr/>
-                    <a:lstStyle/>
-                    <a:p>
-                      <a:r>
-                        <a:rPr sz="1300">
-                          <a:latin typeface="Arial Narrow"/>
-                        </a:rPr>
-                        <a:t>K-Nearest Neighbours</a:t>
-                      </a:r>
-                    </a:p>
-                  </a:txBody>
-                  <a:tcPr/>
-                </a:tc>
-                <a:tc>
-                  <a:txBody>
-                    <a:bodyPr/>
-                    <a:lstStyle/>
-                    <a:p>
-                      <a:r>
-                        <a:rPr sz="1300">
-                          <a:latin typeface="Arial Narrow"/>
-                        </a:rPr>
-                        <a:t>0.830</a:t>
-                      </a:r>
-                    </a:p>
-                  </a:txBody>
-                  <a:tcPr/>
-                </a:tc>
-                <a:tc>
-                  <a:txBody>
-                    <a:bodyPr/>
-                    <a:lstStyle/>
-                    <a:p>
-                      <a:r>
-                        <a:rPr sz="1300">
-                          <a:latin typeface="Arial Narrow"/>
-                        </a:rPr>
-                        <a:t>0.690</a:t>
+                        <a:t>0.720</a:t>
                       </a:r>
                     </a:p>
                   </a:txBody>
@@ -3689,7 +3689,7 @@
                         <a:rPr sz="1300">
                           <a:latin typeface="Arial Narrow"/>
                         </a:rPr>
-                        <a:t>0.719</a:t>
+                        <a:t>0.682</a:t>
                       </a:r>
                     </a:p>
                   </a:txBody>
@@ -3704,7 +3704,7 @@
                         <a:rPr sz="1300">
                           <a:latin typeface="Arial Narrow"/>
                         </a:rPr>
-                        <a:t>0.662</a:t>
+                        <a:t>0.631</a:t>
                       </a:r>
                     </a:p>
                   </a:txBody>
@@ -3937,7 +3937,7 @@
                         <a:rPr sz="1300">
                           <a:latin typeface="Arial Narrow"/>
                         </a:rPr>
-                        <a:t>0.8350</a:t>
+                        <a:t>0.8537</a:t>
                       </a:r>
                     </a:p>
                   </a:txBody>
@@ -3969,7 +3969,7 @@
                         <a:rPr sz="1300">
                           <a:latin typeface="Arial Narrow"/>
                         </a:rPr>
-                        <a:t>0.8372</a:t>
+                        <a:t>0.8317</a:t>
                       </a:r>
                     </a:p>
                   </a:txBody>
@@ -4001,7 +4001,7 @@
                         <a:rPr sz="1300">
                           <a:latin typeface="Arial Narrow"/>
                         </a:rPr>
-                        <a:t>0.9664</a:t>
+                        <a:t>0.9882</a:t>
                       </a:r>
                     </a:p>
                   </a:txBody>
@@ -4033,7 +4033,7 @@
                         <a:rPr sz="1300">
                           <a:latin typeface="Arial Narrow"/>
                         </a:rPr>
-                        <a:t>0.8972</a:t>
+                        <a:t>0.9032</a:t>
                       </a:r>
                     </a:p>
                   </a:txBody>
@@ -4065,7 +4065,7 @@
                         <a:rPr sz="1300">
                           <a:latin typeface="Arial Narrow"/>
                         </a:rPr>
-                        <a:t>0.7627</a:t>
+                        <a:t>0.7867</a:t>
                       </a:r>
                     </a:p>
                   </a:txBody>
@@ -4269,7 +4269,7 @@
               <a:rPr sz="1400" i="1">
                 <a:latin typeface="Arial Narrow"/>
               </a:rPr>
-              <a:t>ROC-AUC = 0.763.</a:t>
+              <a:t>ROC-AUC = 0.787.</a:t>
             </a:r>
           </a:p>
         </p:txBody>
@@ -4735,7 +4735,7 @@
               </a:defRPr>
             </a:pPr>
             <a:r>
-              <a:t>Grid search over 4 parameter combinations.</a:t>
+              <a:t>Grid search over 6 parameter combinations.</a:t>
             </a:r>
           </a:p>
           <a:p>
@@ -4745,7 +4745,7 @@
               </a:defRPr>
             </a:pPr>
             <a:r>
-              <a:t>Best parameters: {'clf__weights': [1, 1, 1]}</a:t>
+              <a:t>Best parameters: {'clf__C': 0.1, 'clf__kernel': 'linear'}</a:t>
             </a:r>
           </a:p>
           <a:p>
@@ -4755,7 +4755,7 @@
               </a:defRPr>
             </a:pPr>
             <a:r>
-              <a:t>Final: 83.5% accuracy, 0.897 F1, 0.763 ROC-AUC.</a:t>
+              <a:t>Final: 85.4% accuracy, 0.903 F1, 0.814 ROC-AUC.</a:t>
             </a:r>
           </a:p>
         </p:txBody>
@@ -4875,7 +4875,7 @@
               </a:defRPr>
             </a:pPr>
             <a:r>
-              <a:t>Results: 83.5% accuracy, 0.763 ROC-AUC</a:t>
+              <a:t>Results: 85.4% accuracy, 0.814 ROC-AUC</a:t>
             </a:r>
           </a:p>
         </p:txBody>
@@ -4974,7 +4974,7 @@
               <a:rPr sz="1400" i="1">
                 <a:latin typeface="Arial Narrow"/>
               </a:rPr>
-              <a:t>Cost ratio 5.0:1.0 -&gt; optimal cut-off 0.27.</a:t>
+              <a:t>Cost ratio 5.0:1.0 -&gt; optimal cut-off 0.1.</a:t>
             </a:r>
           </a:p>
         </p:txBody>
@@ -5253,7 +5253,7 @@
               </a:defRPr>
             </a:pPr>
             <a:r>
-              <a:t>Logistic regression: 83.5% accuracy on unseen data.</a:t>
+              <a:t>Logistic regression: 85.4% accuracy on unseen data.</a:t>
             </a:r>
           </a:p>
           <a:p>

</xml_diff>